<commit_message>
feat: cryo tank management (UI spec + CryoLocation code + inventory), Treatment Planning tab, and tab/attributes workbook
- docs/OXar_Treatment_Cycle_Tab_Attributes.xlsx (+ generator): per-tab attribute
  mapping across 17 tabs with source entity, relationship, data type and status;
  entities & relationships sheet. New Treatment Planning + Three Point Check tabs first.
- docs/07-TREATMENT-PLANNING-TAB.md: Treatment Planning -> Three-Point Check redesign.
- docs/03-FRONTEND-GUIDE.md: cryo tank management UI (tank wall / detail tree /
  inventory) + treatment planning tab section.
- backend/: CryoLocation full CRUD (canister/goblet/straw) + SetStatus, and
  CryoTank/GetInventory (frozen specimens per tank).
- Idiot's Guide deck: +2 slides (Treatment Planning->3PC, Cryo Tank Management); now 25.

Co-Authored-By: Claude Opus 4.8 <noreply@anthropic.com>
Claude-Session: https://claude.ai/code/session_01Dgg7VRGZA7FZRvApuf59qy
</commit_message>
<xml_diff>
--- a/docs/slides/OXar_Embryo_Module_Idiots_Guide.pptx
+++ b/docs/slides/OXar_Embryo_Module_Idiots_Guide.pptx
@@ -28,6 +28,8 @@
     <p:sldId id="276" r:id="rId27"/>
     <p:sldId id="277" r:id="rId28"/>
     <p:sldId id="278" r:id="rId29"/>
+    <p:sldId id="279" r:id="rId30"/>
+    <p:sldId id="280" r:id="rId31"/>
   </p:sldIdLst>
   <p:sldSz cx="12191695" cy="6858000" type="screen4x3"/>
   <p:notesSz cx="6858000" cy="9144000"/>
@@ -26163,6 +26165,2621 @@
                 <a:latin typeface="Lato"/>
               </a:rPr>
               <a:t>Storage location &amp; consent; hide clinical / stimulation fields</a:t>
+            </a:r>
+          </a:p>
+        </p:txBody>
+      </p:sp>
+    </p:spTree>
+  </p:cSld>
+  <p:clrMapOvr>
+    <a:masterClrMapping/>
+  </p:clrMapOvr>
+</p:sld>
+</file>
+
+<file path=ppt/slides/slide24.xml><?xml version="1.0" encoding="utf-8"?>
+<p:sld xmlns:a="http://schemas.openxmlformats.org/drawingml/2006/main" xmlns:p="http://schemas.openxmlformats.org/presentationml/2006/main" xmlns:r="http://schemas.openxmlformats.org/officeDocument/2006/relationships">
+  <p:cSld>
+    <p:bg>
+      <p:bgPr>
+        <a:solidFill>
+          <a:srgbClr val="F5F8F7"/>
+        </a:solidFill>
+        <a:effectLst/>
+      </p:bgPr>
+    </p:bg>
+    <p:spTree>
+      <p:nvGrpSpPr>
+        <p:cNvPr id="1" name=""/>
+        <p:cNvGrpSpPr/>
+        <p:nvPr/>
+      </p:nvGrpSpPr>
+      <p:grpSpPr/>
+      <p:sp>
+        <p:nvSpPr>
+          <p:cNvPr id="2" name="Rectangle 1"/>
+          <p:cNvSpPr/>
+          <p:nvPr/>
+        </p:nvSpPr>
+        <p:spPr>
+          <a:xfrm>
+            <a:off x="0" y="0"/>
+            <a:ext cx="12191695" cy="1051560"/>
+          </a:xfrm>
+          <a:prstGeom prst="rect">
+            <a:avLst/>
+          </a:prstGeom>
+          <a:solidFill>
+            <a:srgbClr val="FFFFFF"/>
+          </a:solidFill>
+          <a:ln>
+            <a:noFill/>
+          </a:ln>
+          <a:effectLst/>
+        </p:spPr>
+        <p:style>
+          <a:lnRef idx="1">
+            <a:schemeClr val="accent1"/>
+          </a:lnRef>
+          <a:fillRef idx="3">
+            <a:schemeClr val="accent1"/>
+          </a:fillRef>
+          <a:effectRef idx="2">
+            <a:schemeClr val="accent1"/>
+          </a:effectRef>
+          <a:fontRef idx="minor">
+            <a:schemeClr val="lt1"/>
+          </a:fontRef>
+        </p:style>
+        <p:txBody>
+          <a:bodyPr rtlCol="0" anchor="ctr"/>
+          <a:lstStyle/>
+          <a:p>
+            <a:pPr algn="ctr"/>
+          </a:p>
+        </p:txBody>
+      </p:sp>
+      <p:sp>
+        <p:nvSpPr>
+          <p:cNvPr id="3" name="Rectangle 2"/>
+          <p:cNvSpPr/>
+          <p:nvPr/>
+        </p:nvSpPr>
+        <p:spPr>
+          <a:xfrm>
+            <a:off x="0" y="1051560"/>
+            <a:ext cx="12191695" cy="38100"/>
+          </a:xfrm>
+          <a:prstGeom prst="rect">
+            <a:avLst/>
+          </a:prstGeom>
+          <a:solidFill>
+            <a:srgbClr val="45A59D"/>
+          </a:solidFill>
+          <a:ln>
+            <a:noFill/>
+          </a:ln>
+          <a:effectLst/>
+        </p:spPr>
+        <p:style>
+          <a:lnRef idx="1">
+            <a:schemeClr val="accent1"/>
+          </a:lnRef>
+          <a:fillRef idx="3">
+            <a:schemeClr val="accent1"/>
+          </a:fillRef>
+          <a:effectRef idx="2">
+            <a:schemeClr val="accent1"/>
+          </a:effectRef>
+          <a:fontRef idx="minor">
+            <a:schemeClr val="lt1"/>
+          </a:fontRef>
+        </p:style>
+        <p:txBody>
+          <a:bodyPr rtlCol="0" anchor="ctr"/>
+          <a:lstStyle/>
+          <a:p>
+            <a:pPr algn="ctr"/>
+          </a:p>
+        </p:txBody>
+      </p:sp>
+      <p:sp>
+        <p:nvSpPr>
+          <p:cNvPr id="4" name="TextBox 3"/>
+          <p:cNvSpPr txBox="1"/>
+          <p:nvPr/>
+        </p:nvSpPr>
+        <p:spPr>
+          <a:xfrm>
+            <a:off x="548640" y="146304"/>
+            <a:ext cx="10058400" cy="365760"/>
+          </a:xfrm>
+          <a:prstGeom prst="rect">
+            <a:avLst/>
+          </a:prstGeom>
+          <a:noFill/>
+        </p:spPr>
+        <p:txBody>
+          <a:bodyPr wrap="square" anchor="t" lIns="25400" rIns="25400" tIns="25400" bIns="25400">
+            <a:spAutoFit/>
+          </a:bodyPr>
+          <a:lstStyle/>
+          <a:p>
+            <a:pPr algn="l">
+              <a:lnSpc>
+                <a:spcPct val="106000"/>
+              </a:lnSpc>
+              <a:spcBef>
+                <a:spcPts val="0"/>
+              </a:spcBef>
+              <a:spcAft>
+                <a:spcPts val="600"/>
+              </a:spcAft>
+            </a:pPr>
+            <a:r>
+              <a:rPr sz="1200" b="1">
+                <a:solidFill>
+                  <a:srgbClr val="2F7D76"/>
+                </a:solidFill>
+                <a:latin typeface="Montserrat"/>
+              </a:rPr>
+              <a:t>TAB REDESIGN</a:t>
+            </a:r>
+          </a:p>
+        </p:txBody>
+      </p:sp>
+      <p:sp>
+        <p:nvSpPr>
+          <p:cNvPr id="5" name="TextBox 4"/>
+          <p:cNvSpPr txBox="1"/>
+          <p:nvPr/>
+        </p:nvSpPr>
+        <p:spPr>
+          <a:xfrm>
+            <a:off x="548640" y="402336"/>
+            <a:ext cx="10515600" cy="640080"/>
+          </a:xfrm>
+          <a:prstGeom prst="rect">
+            <a:avLst/>
+          </a:prstGeom>
+          <a:noFill/>
+        </p:spPr>
+        <p:txBody>
+          <a:bodyPr wrap="square" anchor="t" lIns="25400" rIns="25400" tIns="25400" bIns="25400">
+            <a:spAutoFit/>
+          </a:bodyPr>
+          <a:lstStyle/>
+          <a:p>
+            <a:pPr algn="l">
+              <a:lnSpc>
+                <a:spcPct val="106000"/>
+              </a:lnSpc>
+              <a:spcBef>
+                <a:spcPts val="0"/>
+              </a:spcBef>
+              <a:spcAft>
+                <a:spcPts val="600"/>
+              </a:spcAft>
+            </a:pPr>
+            <a:r>
+              <a:rPr sz="2700" b="1">
+                <a:solidFill>
+                  <a:srgbClr val="221F20"/>
+                </a:solidFill>
+                <a:latin typeface="Montserrat"/>
+              </a:rPr>
+              <a:t>Treatment Planning  →  Three-Point Check</a:t>
+            </a:r>
+          </a:p>
+        </p:txBody>
+      </p:sp>
+      <p:sp>
+        <p:nvSpPr>
+          <p:cNvPr id="6" name="Rounded Rectangle 5"/>
+          <p:cNvSpPr/>
+          <p:nvPr/>
+        </p:nvSpPr>
+        <p:spPr>
+          <a:xfrm>
+            <a:off x="11292840" y="292608"/>
+            <a:ext cx="566928" cy="457200"/>
+          </a:xfrm>
+          <a:prstGeom prst="roundRect">
+            <a:avLst/>
+          </a:prstGeom>
+          <a:solidFill>
+            <a:srgbClr val="EAF5F3"/>
+          </a:solidFill>
+          <a:ln>
+            <a:noFill/>
+          </a:ln>
+          <a:effectLst/>
+        </p:spPr>
+        <p:style>
+          <a:lnRef idx="1">
+            <a:schemeClr val="accent1"/>
+          </a:lnRef>
+          <a:fillRef idx="3">
+            <a:schemeClr val="accent1"/>
+          </a:fillRef>
+          <a:effectRef idx="2">
+            <a:schemeClr val="accent1"/>
+          </a:effectRef>
+          <a:fontRef idx="minor">
+            <a:schemeClr val="lt1"/>
+          </a:fontRef>
+        </p:style>
+        <p:txBody>
+          <a:bodyPr rtlCol="0" anchor="ctr" wrap="none"/>
+          <a:lstStyle/>
+          <a:p>
+            <a:pPr algn="ctr"/>
+            <a:r>
+              <a:rPr sz="1500" b="1">
+                <a:solidFill>
+                  <a:srgbClr val="2F7D76"/>
+                </a:solidFill>
+                <a:latin typeface="Montserrat"/>
+              </a:rPr>
+              <a:t>24</a:t>
+            </a:r>
+          </a:p>
+        </p:txBody>
+      </p:sp>
+      <p:sp>
+        <p:nvSpPr>
+          <p:cNvPr id="7" name="TextBox 6"/>
+          <p:cNvSpPr txBox="1"/>
+          <p:nvPr/>
+        </p:nvSpPr>
+        <p:spPr>
+          <a:xfrm>
+            <a:off x="548640" y="1280160"/>
+            <a:ext cx="11064240" cy="731520"/>
+          </a:xfrm>
+          <a:prstGeom prst="rect">
+            <a:avLst/>
+          </a:prstGeom>
+          <a:noFill/>
+        </p:spPr>
+        <p:txBody>
+          <a:bodyPr wrap="square" anchor="t" lIns="25400" rIns="25400" tIns="25400" bIns="25400">
+            <a:spAutoFit/>
+          </a:bodyPr>
+          <a:lstStyle/>
+          <a:p>
+            <a:pPr algn="l">
+              <a:lnSpc>
+                <a:spcPct val="106000"/>
+              </a:lnSpc>
+              <a:spcBef>
+                <a:spcPts val="0"/>
+              </a:spcBef>
+              <a:spcAft>
+                <a:spcPts val="600"/>
+              </a:spcAft>
+            </a:pPr>
+            <a:r>
+              <a:rPr sz="1600" b="1">
+                <a:solidFill>
+                  <a:srgbClr val="2F7D76"/>
+                </a:solidFill>
+                <a:latin typeface="Lato"/>
+              </a:rPr>
+              <a:t>Plan first, then verify. </a:t>
+            </a:r>
+            <a:r>
+              <a:rPr sz="1600" b="0">
+                <a:solidFill>
+                  <a:srgbClr val="221F20"/>
+                </a:solidFill>
+                <a:latin typeface="Lato"/>
+              </a:rPr>
+              <a:t>The Treatment Planning tab consolidates today's Overview; the treatment type then hides irrelevant fields. The Three-Point Check gates every procedure.</a:t>
+            </a:r>
+          </a:p>
+        </p:txBody>
+      </p:sp>
+      <p:sp>
+        <p:nvSpPr>
+          <p:cNvPr id="8" name="Rounded Rectangle 7"/>
+          <p:cNvSpPr/>
+          <p:nvPr/>
+        </p:nvSpPr>
+        <p:spPr>
+          <a:xfrm>
+            <a:off x="548640" y="2286000"/>
+            <a:ext cx="6766560" cy="3749039"/>
+          </a:xfrm>
+          <a:prstGeom prst="roundRect">
+            <a:avLst/>
+          </a:prstGeom>
+          <a:solidFill>
+            <a:srgbClr val="FFFFFF"/>
+          </a:solidFill>
+          <a:ln w="12700">
+            <a:solidFill>
+              <a:srgbClr val="E4ECEA"/>
+            </a:solidFill>
+          </a:ln>
+          <a:effectLst/>
+        </p:spPr>
+        <p:style>
+          <a:lnRef idx="1">
+            <a:schemeClr val="accent1"/>
+          </a:lnRef>
+          <a:fillRef idx="3">
+            <a:schemeClr val="accent1"/>
+          </a:fillRef>
+          <a:effectRef idx="2">
+            <a:schemeClr val="accent1"/>
+          </a:effectRef>
+          <a:fontRef idx="minor">
+            <a:schemeClr val="lt1"/>
+          </a:fontRef>
+        </p:style>
+        <p:txBody>
+          <a:bodyPr rtlCol="0" anchor="ctr"/>
+          <a:lstStyle/>
+          <a:p>
+            <a:pPr algn="ctr"/>
+          </a:p>
+        </p:txBody>
+      </p:sp>
+      <p:sp>
+        <p:nvSpPr>
+          <p:cNvPr id="9" name="Rectangle 8"/>
+          <p:cNvSpPr/>
+          <p:nvPr/>
+        </p:nvSpPr>
+        <p:spPr>
+          <a:xfrm>
+            <a:off x="548640" y="2286000"/>
+            <a:ext cx="6766560" cy="109728"/>
+          </a:xfrm>
+          <a:prstGeom prst="rect">
+            <a:avLst/>
+          </a:prstGeom>
+          <a:solidFill>
+            <a:srgbClr val="45A59D"/>
+          </a:solidFill>
+          <a:ln>
+            <a:noFill/>
+          </a:ln>
+          <a:effectLst/>
+        </p:spPr>
+        <p:style>
+          <a:lnRef idx="1">
+            <a:schemeClr val="accent1"/>
+          </a:lnRef>
+          <a:fillRef idx="3">
+            <a:schemeClr val="accent1"/>
+          </a:fillRef>
+          <a:effectRef idx="2">
+            <a:schemeClr val="accent1"/>
+          </a:effectRef>
+          <a:fontRef idx="minor">
+            <a:schemeClr val="lt1"/>
+          </a:fontRef>
+        </p:style>
+        <p:txBody>
+          <a:bodyPr rtlCol="0" anchor="ctr"/>
+          <a:lstStyle/>
+          <a:p>
+            <a:pPr algn="ctr"/>
+          </a:p>
+        </p:txBody>
+      </p:sp>
+      <p:sp>
+        <p:nvSpPr>
+          <p:cNvPr id="10" name="TextBox 9"/>
+          <p:cNvSpPr txBox="1"/>
+          <p:nvPr/>
+        </p:nvSpPr>
+        <p:spPr>
+          <a:xfrm>
+            <a:off x="777240" y="2468880"/>
+            <a:ext cx="6400800" cy="365760"/>
+          </a:xfrm>
+          <a:prstGeom prst="rect">
+            <a:avLst/>
+          </a:prstGeom>
+          <a:noFill/>
+        </p:spPr>
+        <p:txBody>
+          <a:bodyPr wrap="square" anchor="t" lIns="25400" rIns="25400" tIns="25400" bIns="25400">
+            <a:spAutoFit/>
+          </a:bodyPr>
+          <a:lstStyle/>
+          <a:p>
+            <a:pPr algn="l">
+              <a:lnSpc>
+                <a:spcPct val="106000"/>
+              </a:lnSpc>
+              <a:spcBef>
+                <a:spcPts val="0"/>
+              </a:spcBef>
+              <a:spcAft>
+                <a:spcPts val="600"/>
+              </a:spcAft>
+            </a:pPr>
+            <a:r>
+              <a:rPr sz="1300" b="1">
+                <a:solidFill>
+                  <a:srgbClr val="2F7D76"/>
+                </a:solidFill>
+                <a:latin typeface="Montserrat"/>
+              </a:rPr>
+              <a:t>1 · TREATMENT PLANNING</a:t>
+            </a:r>
+          </a:p>
+        </p:txBody>
+      </p:sp>
+      <p:sp>
+        <p:nvSpPr>
+          <p:cNvPr id="11" name="Rectangle 10"/>
+          <p:cNvSpPr/>
+          <p:nvPr/>
+        </p:nvSpPr>
+        <p:spPr>
+          <a:xfrm>
+            <a:off x="822960" y="2980944"/>
+            <a:ext cx="128016" cy="128016"/>
+          </a:xfrm>
+          <a:prstGeom prst="rect">
+            <a:avLst/>
+          </a:prstGeom>
+          <a:solidFill>
+            <a:srgbClr val="45A59D"/>
+          </a:solidFill>
+          <a:ln>
+            <a:noFill/>
+          </a:ln>
+          <a:effectLst/>
+        </p:spPr>
+        <p:style>
+          <a:lnRef idx="1">
+            <a:schemeClr val="accent1"/>
+          </a:lnRef>
+          <a:fillRef idx="3">
+            <a:schemeClr val="accent1"/>
+          </a:fillRef>
+          <a:effectRef idx="2">
+            <a:schemeClr val="accent1"/>
+          </a:effectRef>
+          <a:fontRef idx="minor">
+            <a:schemeClr val="lt1"/>
+          </a:fontRef>
+        </p:style>
+        <p:txBody>
+          <a:bodyPr rtlCol="0" anchor="ctr"/>
+          <a:lstStyle/>
+          <a:p>
+            <a:pPr algn="ctr"/>
+          </a:p>
+        </p:txBody>
+      </p:sp>
+      <p:sp>
+        <p:nvSpPr>
+          <p:cNvPr id="12" name="TextBox 11"/>
+          <p:cNvSpPr txBox="1"/>
+          <p:nvPr/>
+        </p:nvSpPr>
+        <p:spPr>
+          <a:xfrm>
+            <a:off x="1097280" y="2889504"/>
+            <a:ext cx="6126480" cy="548640"/>
+          </a:xfrm>
+          <a:prstGeom prst="rect">
+            <a:avLst/>
+          </a:prstGeom>
+          <a:noFill/>
+        </p:spPr>
+        <p:txBody>
+          <a:bodyPr wrap="square" anchor="t" lIns="25400" rIns="25400" tIns="25400" bIns="25400">
+            <a:spAutoFit/>
+          </a:bodyPr>
+          <a:lstStyle/>
+          <a:p>
+            <a:pPr algn="l">
+              <a:lnSpc>
+                <a:spcPct val="106000"/>
+              </a:lnSpc>
+              <a:spcBef>
+                <a:spcPts val="0"/>
+              </a:spcBef>
+              <a:spcAft>
+                <a:spcPts val="600"/>
+              </a:spcAft>
+            </a:pPr>
+            <a:r>
+              <a:rPr sz="1300" b="1">
+                <a:solidFill>
+                  <a:srgbClr val="221F20"/>
+                </a:solidFill>
+                <a:latin typeface="Lato"/>
+              </a:rPr>
+              <a:t>Cycle Information  </a:t>
+            </a:r>
+            <a:r>
+              <a:rPr sz="1200" b="0">
+                <a:solidFill>
+                  <a:srgbClr val="6C7C7A"/>
+                </a:solidFill>
+                <a:latin typeface="Lato"/>
+              </a:rPr>
+              <a:t>type, template, billing, ANZARD, instructions</a:t>
+            </a:r>
+          </a:p>
+        </p:txBody>
+      </p:sp>
+      <p:sp>
+        <p:nvSpPr>
+          <p:cNvPr id="13" name="Rectangle 12"/>
+          <p:cNvSpPr/>
+          <p:nvPr/>
+        </p:nvSpPr>
+        <p:spPr>
+          <a:xfrm>
+            <a:off x="822960" y="3547872"/>
+            <a:ext cx="128016" cy="128016"/>
+          </a:xfrm>
+          <a:prstGeom prst="rect">
+            <a:avLst/>
+          </a:prstGeom>
+          <a:solidFill>
+            <a:srgbClr val="45A59D"/>
+          </a:solidFill>
+          <a:ln>
+            <a:noFill/>
+          </a:ln>
+          <a:effectLst/>
+        </p:spPr>
+        <p:style>
+          <a:lnRef idx="1">
+            <a:schemeClr val="accent1"/>
+          </a:lnRef>
+          <a:fillRef idx="3">
+            <a:schemeClr val="accent1"/>
+          </a:fillRef>
+          <a:effectRef idx="2">
+            <a:schemeClr val="accent1"/>
+          </a:effectRef>
+          <a:fontRef idx="minor">
+            <a:schemeClr val="lt1"/>
+          </a:fontRef>
+        </p:style>
+        <p:txBody>
+          <a:bodyPr rtlCol="0" anchor="ctr"/>
+          <a:lstStyle/>
+          <a:p>
+            <a:pPr algn="ctr"/>
+          </a:p>
+        </p:txBody>
+      </p:sp>
+      <p:sp>
+        <p:nvSpPr>
+          <p:cNvPr id="14" name="TextBox 13"/>
+          <p:cNvSpPr txBox="1"/>
+          <p:nvPr/>
+        </p:nvSpPr>
+        <p:spPr>
+          <a:xfrm>
+            <a:off x="1097280" y="3456432"/>
+            <a:ext cx="6126480" cy="548640"/>
+          </a:xfrm>
+          <a:prstGeom prst="rect">
+            <a:avLst/>
+          </a:prstGeom>
+          <a:noFill/>
+        </p:spPr>
+        <p:txBody>
+          <a:bodyPr wrap="square" anchor="t" lIns="25400" rIns="25400" tIns="25400" bIns="25400">
+            <a:spAutoFit/>
+          </a:bodyPr>
+          <a:lstStyle/>
+          <a:p>
+            <a:pPr algn="l">
+              <a:lnSpc>
+                <a:spcPct val="106000"/>
+              </a:lnSpc>
+              <a:spcBef>
+                <a:spcPts val="0"/>
+              </a:spcBef>
+              <a:spcAft>
+                <a:spcPts val="600"/>
+              </a:spcAft>
+            </a:pPr>
+            <a:r>
+              <a:rPr sz="1300" b="1">
+                <a:solidFill>
+                  <a:srgbClr val="221F20"/>
+                </a:solidFill>
+                <a:latin typeface="Lato"/>
+              </a:rPr>
+              <a:t>People  </a:t>
+            </a:r>
+            <a:r>
+              <a:rPr sz="1200" b="0">
+                <a:solidFill>
+                  <a:srgbClr val="6C7C7A"/>
+                </a:solidFill>
+                <a:latin typeface="Lato"/>
+              </a:rPr>
+              <a:t>patient, partner, doctor, nurse, groups</a:t>
+            </a:r>
+          </a:p>
+        </p:txBody>
+      </p:sp>
+      <p:sp>
+        <p:nvSpPr>
+          <p:cNvPr id="15" name="Rectangle 14"/>
+          <p:cNvSpPr/>
+          <p:nvPr/>
+        </p:nvSpPr>
+        <p:spPr>
+          <a:xfrm>
+            <a:off x="822960" y="4114800"/>
+            <a:ext cx="128016" cy="128016"/>
+          </a:xfrm>
+          <a:prstGeom prst="rect">
+            <a:avLst/>
+          </a:prstGeom>
+          <a:solidFill>
+            <a:srgbClr val="45A59D"/>
+          </a:solidFill>
+          <a:ln>
+            <a:noFill/>
+          </a:ln>
+          <a:effectLst/>
+        </p:spPr>
+        <p:style>
+          <a:lnRef idx="1">
+            <a:schemeClr val="accent1"/>
+          </a:lnRef>
+          <a:fillRef idx="3">
+            <a:schemeClr val="accent1"/>
+          </a:fillRef>
+          <a:effectRef idx="2">
+            <a:schemeClr val="accent1"/>
+          </a:effectRef>
+          <a:fontRef idx="minor">
+            <a:schemeClr val="lt1"/>
+          </a:fontRef>
+        </p:style>
+        <p:txBody>
+          <a:bodyPr rtlCol="0" anchor="ctr"/>
+          <a:lstStyle/>
+          <a:p>
+            <a:pPr algn="ctr"/>
+          </a:p>
+        </p:txBody>
+      </p:sp>
+      <p:sp>
+        <p:nvSpPr>
+          <p:cNvPr id="16" name="TextBox 15"/>
+          <p:cNvSpPr txBox="1"/>
+          <p:nvPr/>
+        </p:nvSpPr>
+        <p:spPr>
+          <a:xfrm>
+            <a:off x="1097280" y="4023360"/>
+            <a:ext cx="6126480" cy="548640"/>
+          </a:xfrm>
+          <a:prstGeom prst="rect">
+            <a:avLst/>
+          </a:prstGeom>
+          <a:noFill/>
+        </p:spPr>
+        <p:txBody>
+          <a:bodyPr wrap="square" anchor="t" lIns="25400" rIns="25400" tIns="25400" bIns="25400">
+            <a:spAutoFit/>
+          </a:bodyPr>
+          <a:lstStyle/>
+          <a:p>
+            <a:pPr algn="l">
+              <a:lnSpc>
+                <a:spcPct val="106000"/>
+              </a:lnSpc>
+              <a:spcBef>
+                <a:spcPts val="0"/>
+              </a:spcBef>
+              <a:spcAft>
+                <a:spcPts val="600"/>
+              </a:spcAft>
+            </a:pPr>
+            <a:r>
+              <a:rPr sz="1300" b="1">
+                <a:solidFill>
+                  <a:srgbClr val="221F20"/>
+                </a:solidFill>
+                <a:latin typeface="Lato"/>
+              </a:rPr>
+              <a:t>Clinic &amp; Dates  </a:t>
+            </a:r>
+            <a:r>
+              <a:rPr sz="1200" b="0">
+                <a:solidFill>
+                  <a:srgbClr val="6C7C7A"/>
+                </a:solidFill>
+                <a:latin typeface="Lato"/>
+              </a:rPr>
+              <a:t>managing/procedure clinic, start &amp; period dates</a:t>
+            </a:r>
+          </a:p>
+        </p:txBody>
+      </p:sp>
+      <p:sp>
+        <p:nvSpPr>
+          <p:cNvPr id="17" name="Rectangle 16"/>
+          <p:cNvSpPr/>
+          <p:nvPr/>
+        </p:nvSpPr>
+        <p:spPr>
+          <a:xfrm>
+            <a:off x="822960" y="4681728"/>
+            <a:ext cx="128016" cy="128016"/>
+          </a:xfrm>
+          <a:prstGeom prst="rect">
+            <a:avLst/>
+          </a:prstGeom>
+          <a:solidFill>
+            <a:srgbClr val="45A59D"/>
+          </a:solidFill>
+          <a:ln>
+            <a:noFill/>
+          </a:ln>
+          <a:effectLst/>
+        </p:spPr>
+        <p:style>
+          <a:lnRef idx="1">
+            <a:schemeClr val="accent1"/>
+          </a:lnRef>
+          <a:fillRef idx="3">
+            <a:schemeClr val="accent1"/>
+          </a:fillRef>
+          <a:effectRef idx="2">
+            <a:schemeClr val="accent1"/>
+          </a:effectRef>
+          <a:fontRef idx="minor">
+            <a:schemeClr val="lt1"/>
+          </a:fontRef>
+        </p:style>
+        <p:txBody>
+          <a:bodyPr rtlCol="0" anchor="ctr"/>
+          <a:lstStyle/>
+          <a:p>
+            <a:pPr algn="ctr"/>
+          </a:p>
+        </p:txBody>
+      </p:sp>
+      <p:sp>
+        <p:nvSpPr>
+          <p:cNvPr id="18" name="TextBox 17"/>
+          <p:cNvSpPr txBox="1"/>
+          <p:nvPr/>
+        </p:nvSpPr>
+        <p:spPr>
+          <a:xfrm>
+            <a:off x="1097280" y="4590288"/>
+            <a:ext cx="6126480" cy="548640"/>
+          </a:xfrm>
+          <a:prstGeom prst="rect">
+            <a:avLst/>
+          </a:prstGeom>
+          <a:noFill/>
+        </p:spPr>
+        <p:txBody>
+          <a:bodyPr wrap="square" anchor="t" lIns="25400" rIns="25400" tIns="25400" bIns="25400">
+            <a:spAutoFit/>
+          </a:bodyPr>
+          <a:lstStyle/>
+          <a:p>
+            <a:pPr algn="l">
+              <a:lnSpc>
+                <a:spcPct val="106000"/>
+              </a:lnSpc>
+              <a:spcBef>
+                <a:spcPts val="0"/>
+              </a:spcBef>
+              <a:spcAft>
+                <a:spcPts val="600"/>
+              </a:spcAft>
+            </a:pPr>
+            <a:r>
+              <a:rPr sz="1300" b="1">
+                <a:solidFill>
+                  <a:srgbClr val="221F20"/>
+                </a:solidFill>
+                <a:latin typeface="Lato"/>
+              </a:rPr>
+              <a:t>Diagnosis  </a:t>
+            </a:r>
+            <a:r>
+              <a:rPr sz="1200" b="0">
+                <a:solidFill>
+                  <a:srgbClr val="6C7C7A"/>
+                </a:solidFill>
+                <a:latin typeface="Lato"/>
+              </a:rPr>
+              <a:t>female / male infertility + comment</a:t>
+            </a:r>
+          </a:p>
+        </p:txBody>
+      </p:sp>
+      <p:sp>
+        <p:nvSpPr>
+          <p:cNvPr id="19" name="Rectangle 18"/>
+          <p:cNvSpPr/>
+          <p:nvPr/>
+        </p:nvSpPr>
+        <p:spPr>
+          <a:xfrm>
+            <a:off x="822960" y="5248656"/>
+            <a:ext cx="128016" cy="128016"/>
+          </a:xfrm>
+          <a:prstGeom prst="rect">
+            <a:avLst/>
+          </a:prstGeom>
+          <a:solidFill>
+            <a:srgbClr val="45A59D"/>
+          </a:solidFill>
+          <a:ln>
+            <a:noFill/>
+          </a:ln>
+          <a:effectLst/>
+        </p:spPr>
+        <p:style>
+          <a:lnRef idx="1">
+            <a:schemeClr val="accent1"/>
+          </a:lnRef>
+          <a:fillRef idx="3">
+            <a:schemeClr val="accent1"/>
+          </a:fillRef>
+          <a:effectRef idx="2">
+            <a:schemeClr val="accent1"/>
+          </a:effectRef>
+          <a:fontRef idx="minor">
+            <a:schemeClr val="lt1"/>
+          </a:fontRef>
+        </p:style>
+        <p:txBody>
+          <a:bodyPr rtlCol="0" anchor="ctr"/>
+          <a:lstStyle/>
+          <a:p>
+            <a:pPr algn="ctr"/>
+          </a:p>
+        </p:txBody>
+      </p:sp>
+      <p:sp>
+        <p:nvSpPr>
+          <p:cNvPr id="20" name="TextBox 19"/>
+          <p:cNvSpPr txBox="1"/>
+          <p:nvPr/>
+        </p:nvSpPr>
+        <p:spPr>
+          <a:xfrm>
+            <a:off x="1097280" y="5157216"/>
+            <a:ext cx="6126480" cy="548640"/>
+          </a:xfrm>
+          <a:prstGeom prst="rect">
+            <a:avLst/>
+          </a:prstGeom>
+          <a:noFill/>
+        </p:spPr>
+        <p:txBody>
+          <a:bodyPr wrap="square" anchor="t" lIns="25400" rIns="25400" tIns="25400" bIns="25400">
+            <a:spAutoFit/>
+          </a:bodyPr>
+          <a:lstStyle/>
+          <a:p>
+            <a:pPr algn="l">
+              <a:lnSpc>
+                <a:spcPct val="106000"/>
+              </a:lnSpc>
+              <a:spcBef>
+                <a:spcPts val="0"/>
+              </a:spcBef>
+              <a:spcAft>
+                <a:spcPts val="600"/>
+              </a:spcAft>
+            </a:pPr>
+            <a:r>
+              <a:rPr sz="1300" b="1">
+                <a:solidFill>
+                  <a:srgbClr val="221F20"/>
+                </a:solidFill>
+                <a:latin typeface="Lato"/>
+              </a:rPr>
+              <a:t>Plan (new)  </a:t>
+            </a:r>
+            <a:r>
+              <a:rPr sz="1200" b="0">
+                <a:solidFill>
+                  <a:srgbClr val="6C7C7A"/>
+                </a:solidFill>
+                <a:latin typeface="Lato"/>
+              </a:rPr>
+              <a:t>Event Template (seeds worklist) + Research Project</a:t>
+            </a:r>
+          </a:p>
+        </p:txBody>
+      </p:sp>
+      <p:sp>
+        <p:nvSpPr>
+          <p:cNvPr id="21" name="Rounded Rectangle 20"/>
+          <p:cNvSpPr/>
+          <p:nvPr/>
+        </p:nvSpPr>
+        <p:spPr>
+          <a:xfrm>
+            <a:off x="7498079" y="2286000"/>
+            <a:ext cx="4297680" cy="3749039"/>
+          </a:xfrm>
+          <a:prstGeom prst="roundRect">
+            <a:avLst/>
+          </a:prstGeom>
+          <a:solidFill>
+            <a:srgbClr val="FFFFFF"/>
+          </a:solidFill>
+          <a:ln w="12700">
+            <a:solidFill>
+              <a:srgbClr val="E4ECEA"/>
+            </a:solidFill>
+          </a:ln>
+          <a:effectLst/>
+        </p:spPr>
+        <p:style>
+          <a:lnRef idx="1">
+            <a:schemeClr val="accent1"/>
+          </a:lnRef>
+          <a:fillRef idx="3">
+            <a:schemeClr val="accent1"/>
+          </a:fillRef>
+          <a:effectRef idx="2">
+            <a:schemeClr val="accent1"/>
+          </a:effectRef>
+          <a:fontRef idx="minor">
+            <a:schemeClr val="lt1"/>
+          </a:fontRef>
+        </p:style>
+        <p:txBody>
+          <a:bodyPr rtlCol="0" anchor="ctr"/>
+          <a:lstStyle/>
+          <a:p>
+            <a:pPr algn="ctr"/>
+          </a:p>
+        </p:txBody>
+      </p:sp>
+      <p:sp>
+        <p:nvSpPr>
+          <p:cNvPr id="22" name="Rectangle 21"/>
+          <p:cNvSpPr/>
+          <p:nvPr/>
+        </p:nvSpPr>
+        <p:spPr>
+          <a:xfrm>
+            <a:off x="7498079" y="2286000"/>
+            <a:ext cx="4297680" cy="109728"/>
+          </a:xfrm>
+          <a:prstGeom prst="rect">
+            <a:avLst/>
+          </a:prstGeom>
+          <a:solidFill>
+            <a:srgbClr val="CF4A4A"/>
+          </a:solidFill>
+          <a:ln>
+            <a:noFill/>
+          </a:ln>
+          <a:effectLst/>
+        </p:spPr>
+        <p:style>
+          <a:lnRef idx="1">
+            <a:schemeClr val="accent1"/>
+          </a:lnRef>
+          <a:fillRef idx="3">
+            <a:schemeClr val="accent1"/>
+          </a:fillRef>
+          <a:effectRef idx="2">
+            <a:schemeClr val="accent1"/>
+          </a:effectRef>
+          <a:fontRef idx="minor">
+            <a:schemeClr val="lt1"/>
+          </a:fontRef>
+        </p:style>
+        <p:txBody>
+          <a:bodyPr rtlCol="0" anchor="ctr"/>
+          <a:lstStyle/>
+          <a:p>
+            <a:pPr algn="ctr"/>
+          </a:p>
+        </p:txBody>
+      </p:sp>
+      <p:sp>
+        <p:nvSpPr>
+          <p:cNvPr id="23" name="TextBox 22"/>
+          <p:cNvSpPr txBox="1"/>
+          <p:nvPr/>
+        </p:nvSpPr>
+        <p:spPr>
+          <a:xfrm>
+            <a:off x="7726679" y="2468880"/>
+            <a:ext cx="3840480" cy="365760"/>
+          </a:xfrm>
+          <a:prstGeom prst="rect">
+            <a:avLst/>
+          </a:prstGeom>
+          <a:noFill/>
+        </p:spPr>
+        <p:txBody>
+          <a:bodyPr wrap="square" anchor="t" lIns="25400" rIns="25400" tIns="25400" bIns="25400">
+            <a:spAutoFit/>
+          </a:bodyPr>
+          <a:lstStyle/>
+          <a:p>
+            <a:pPr algn="l">
+              <a:lnSpc>
+                <a:spcPct val="106000"/>
+              </a:lnSpc>
+              <a:spcBef>
+                <a:spcPts val="0"/>
+              </a:spcBef>
+              <a:spcAft>
+                <a:spcPts val="600"/>
+              </a:spcAft>
+            </a:pPr>
+            <a:r>
+              <a:rPr sz="1300" b="1">
+                <a:solidFill>
+                  <a:srgbClr val="CF4A4A"/>
+                </a:solidFill>
+                <a:latin typeface="Montserrat"/>
+              </a:rPr>
+              <a:t>2 · THREE-POINT CHECK</a:t>
+            </a:r>
+          </a:p>
+        </p:txBody>
+      </p:sp>
+      <p:sp>
+        <p:nvSpPr>
+          <p:cNvPr id="24" name="Oval 23"/>
+          <p:cNvSpPr/>
+          <p:nvPr/>
+        </p:nvSpPr>
+        <p:spPr>
+          <a:xfrm>
+            <a:off x="7772400" y="2990088"/>
+            <a:ext cx="237744" cy="237744"/>
+          </a:xfrm>
+          <a:prstGeom prst="ellipse">
+            <a:avLst/>
+          </a:prstGeom>
+          <a:solidFill>
+            <a:srgbClr val="2F9E6F"/>
+          </a:solidFill>
+          <a:ln>
+            <a:noFill/>
+          </a:ln>
+          <a:effectLst/>
+        </p:spPr>
+        <p:style>
+          <a:lnRef idx="1">
+            <a:schemeClr val="accent1"/>
+          </a:lnRef>
+          <a:fillRef idx="3">
+            <a:schemeClr val="accent1"/>
+          </a:fillRef>
+          <a:effectRef idx="2">
+            <a:schemeClr val="accent1"/>
+          </a:effectRef>
+          <a:fontRef idx="minor">
+            <a:schemeClr val="lt1"/>
+          </a:fontRef>
+        </p:style>
+        <p:txBody>
+          <a:bodyPr rtlCol="0" anchor="ctr"/>
+          <a:lstStyle/>
+          <a:p>
+            <a:pPr algn="ctr"/>
+            <a:r>
+              <a:rPr sz="1000" b="1">
+                <a:solidFill>
+                  <a:srgbClr val="FFFFFF"/>
+                </a:solidFill>
+                <a:latin typeface="Montserrat"/>
+              </a:rPr>
+              <a:t>✓</a:t>
+            </a:r>
+          </a:p>
+        </p:txBody>
+      </p:sp>
+      <p:sp>
+        <p:nvSpPr>
+          <p:cNvPr id="25" name="TextBox 24"/>
+          <p:cNvSpPr txBox="1"/>
+          <p:nvPr/>
+        </p:nvSpPr>
+        <p:spPr>
+          <a:xfrm>
+            <a:off x="8138160" y="2944368"/>
+            <a:ext cx="3566160" cy="457200"/>
+          </a:xfrm>
+          <a:prstGeom prst="rect">
+            <a:avLst/>
+          </a:prstGeom>
+          <a:noFill/>
+        </p:spPr>
+        <p:txBody>
+          <a:bodyPr wrap="square" anchor="t" lIns="25400" rIns="25400" tIns="25400" bIns="25400">
+            <a:spAutoFit/>
+          </a:bodyPr>
+          <a:lstStyle/>
+          <a:p>
+            <a:pPr algn="l">
+              <a:lnSpc>
+                <a:spcPct val="106000"/>
+              </a:lnSpc>
+              <a:spcBef>
+                <a:spcPts val="0"/>
+              </a:spcBef>
+              <a:spcAft>
+                <a:spcPts val="600"/>
+              </a:spcAft>
+            </a:pPr>
+            <a:r>
+              <a:rPr sz="1250" b="0">
+                <a:solidFill>
+                  <a:srgbClr val="221F20"/>
+                </a:solidFill>
+                <a:latin typeface="Lato"/>
+              </a:rPr>
+              <a:t>Patient verified</a:t>
+            </a:r>
+          </a:p>
+        </p:txBody>
+      </p:sp>
+      <p:sp>
+        <p:nvSpPr>
+          <p:cNvPr id="26" name="Oval 25"/>
+          <p:cNvSpPr/>
+          <p:nvPr/>
+        </p:nvSpPr>
+        <p:spPr>
+          <a:xfrm>
+            <a:off x="7772400" y="3538728"/>
+            <a:ext cx="237744" cy="237744"/>
+          </a:xfrm>
+          <a:prstGeom prst="ellipse">
+            <a:avLst/>
+          </a:prstGeom>
+          <a:solidFill>
+            <a:srgbClr val="2F9E6F"/>
+          </a:solidFill>
+          <a:ln>
+            <a:noFill/>
+          </a:ln>
+          <a:effectLst/>
+        </p:spPr>
+        <p:style>
+          <a:lnRef idx="1">
+            <a:schemeClr val="accent1"/>
+          </a:lnRef>
+          <a:fillRef idx="3">
+            <a:schemeClr val="accent1"/>
+          </a:fillRef>
+          <a:effectRef idx="2">
+            <a:schemeClr val="accent1"/>
+          </a:effectRef>
+          <a:fontRef idx="minor">
+            <a:schemeClr val="lt1"/>
+          </a:fontRef>
+        </p:style>
+        <p:txBody>
+          <a:bodyPr rtlCol="0" anchor="ctr"/>
+          <a:lstStyle/>
+          <a:p>
+            <a:pPr algn="ctr"/>
+            <a:r>
+              <a:rPr sz="1000" b="1">
+                <a:solidFill>
+                  <a:srgbClr val="FFFFFF"/>
+                </a:solidFill>
+                <a:latin typeface="Montserrat"/>
+              </a:rPr>
+              <a:t>✓</a:t>
+            </a:r>
+          </a:p>
+        </p:txBody>
+      </p:sp>
+      <p:sp>
+        <p:nvSpPr>
+          <p:cNvPr id="27" name="TextBox 26"/>
+          <p:cNvSpPr txBox="1"/>
+          <p:nvPr/>
+        </p:nvSpPr>
+        <p:spPr>
+          <a:xfrm>
+            <a:off x="8138160" y="3493008"/>
+            <a:ext cx="3566160" cy="457200"/>
+          </a:xfrm>
+          <a:prstGeom prst="rect">
+            <a:avLst/>
+          </a:prstGeom>
+          <a:noFill/>
+        </p:spPr>
+        <p:txBody>
+          <a:bodyPr wrap="square" anchor="t" lIns="25400" rIns="25400" tIns="25400" bIns="25400">
+            <a:spAutoFit/>
+          </a:bodyPr>
+          <a:lstStyle/>
+          <a:p>
+            <a:pPr algn="l">
+              <a:lnSpc>
+                <a:spcPct val="106000"/>
+              </a:lnSpc>
+              <a:spcBef>
+                <a:spcPts val="0"/>
+              </a:spcBef>
+              <a:spcAft>
+                <a:spcPts val="600"/>
+              </a:spcAft>
+            </a:pPr>
+            <a:r>
+              <a:rPr sz="1250" b="0">
+                <a:solidFill>
+                  <a:srgbClr val="221F20"/>
+                </a:solidFill>
+                <a:latin typeface="Lato"/>
+              </a:rPr>
+              <a:t>Partner verified</a:t>
+            </a:r>
+          </a:p>
+        </p:txBody>
+      </p:sp>
+      <p:sp>
+        <p:nvSpPr>
+          <p:cNvPr id="28" name="Oval 27"/>
+          <p:cNvSpPr/>
+          <p:nvPr/>
+        </p:nvSpPr>
+        <p:spPr>
+          <a:xfrm>
+            <a:off x="7772400" y="4087368"/>
+            <a:ext cx="237744" cy="237744"/>
+          </a:xfrm>
+          <a:prstGeom prst="ellipse">
+            <a:avLst/>
+          </a:prstGeom>
+          <a:solidFill>
+            <a:srgbClr val="2F9E6F"/>
+          </a:solidFill>
+          <a:ln>
+            <a:noFill/>
+          </a:ln>
+          <a:effectLst/>
+        </p:spPr>
+        <p:style>
+          <a:lnRef idx="1">
+            <a:schemeClr val="accent1"/>
+          </a:lnRef>
+          <a:fillRef idx="3">
+            <a:schemeClr val="accent1"/>
+          </a:fillRef>
+          <a:effectRef idx="2">
+            <a:schemeClr val="accent1"/>
+          </a:effectRef>
+          <a:fontRef idx="minor">
+            <a:schemeClr val="lt1"/>
+          </a:fontRef>
+        </p:style>
+        <p:txBody>
+          <a:bodyPr rtlCol="0" anchor="ctr"/>
+          <a:lstStyle/>
+          <a:p>
+            <a:pPr algn="ctr"/>
+            <a:r>
+              <a:rPr sz="1000" b="1">
+                <a:solidFill>
+                  <a:srgbClr val="FFFFFF"/>
+                </a:solidFill>
+                <a:latin typeface="Montserrat"/>
+              </a:rPr>
+              <a:t>✓</a:t>
+            </a:r>
+          </a:p>
+        </p:txBody>
+      </p:sp>
+      <p:sp>
+        <p:nvSpPr>
+          <p:cNvPr id="29" name="TextBox 28"/>
+          <p:cNvSpPr txBox="1"/>
+          <p:nvPr/>
+        </p:nvSpPr>
+        <p:spPr>
+          <a:xfrm>
+            <a:off x="8138160" y="4041648"/>
+            <a:ext cx="3566160" cy="457200"/>
+          </a:xfrm>
+          <a:prstGeom prst="rect">
+            <a:avLst/>
+          </a:prstGeom>
+          <a:noFill/>
+        </p:spPr>
+        <p:txBody>
+          <a:bodyPr wrap="square" anchor="t" lIns="25400" rIns="25400" tIns="25400" bIns="25400">
+            <a:spAutoFit/>
+          </a:bodyPr>
+          <a:lstStyle/>
+          <a:p>
+            <a:pPr algn="l">
+              <a:lnSpc>
+                <a:spcPct val="106000"/>
+              </a:lnSpc>
+              <a:spcBef>
+                <a:spcPts val="0"/>
+              </a:spcBef>
+              <a:spcAft>
+                <a:spcPts val="600"/>
+              </a:spcAft>
+            </a:pPr>
+            <a:r>
+              <a:rPr sz="1250" b="0">
+                <a:solidFill>
+                  <a:srgbClr val="221F20"/>
+                </a:solidFill>
+                <a:latin typeface="Lato"/>
+              </a:rPr>
+              <a:t>Consent verified</a:t>
+            </a:r>
+          </a:p>
+        </p:txBody>
+      </p:sp>
+      <p:sp>
+        <p:nvSpPr>
+          <p:cNvPr id="30" name="Oval 29"/>
+          <p:cNvSpPr/>
+          <p:nvPr/>
+        </p:nvSpPr>
+        <p:spPr>
+          <a:xfrm>
+            <a:off x="7772400" y="4636008"/>
+            <a:ext cx="237744" cy="237744"/>
+          </a:xfrm>
+          <a:prstGeom prst="ellipse">
+            <a:avLst/>
+          </a:prstGeom>
+          <a:solidFill>
+            <a:srgbClr val="2F9E6F"/>
+          </a:solidFill>
+          <a:ln>
+            <a:noFill/>
+          </a:ln>
+          <a:effectLst/>
+        </p:spPr>
+        <p:style>
+          <a:lnRef idx="1">
+            <a:schemeClr val="accent1"/>
+          </a:lnRef>
+          <a:fillRef idx="3">
+            <a:schemeClr val="accent1"/>
+          </a:fillRef>
+          <a:effectRef idx="2">
+            <a:schemeClr val="accent1"/>
+          </a:effectRef>
+          <a:fontRef idx="minor">
+            <a:schemeClr val="lt1"/>
+          </a:fontRef>
+        </p:style>
+        <p:txBody>
+          <a:bodyPr rtlCol="0" anchor="ctr"/>
+          <a:lstStyle/>
+          <a:p>
+            <a:pPr algn="ctr"/>
+            <a:r>
+              <a:rPr sz="1000" b="1">
+                <a:solidFill>
+                  <a:srgbClr val="FFFFFF"/>
+                </a:solidFill>
+                <a:latin typeface="Montserrat"/>
+              </a:rPr>
+              <a:t>✓</a:t>
+            </a:r>
+          </a:p>
+        </p:txBody>
+      </p:sp>
+      <p:sp>
+        <p:nvSpPr>
+          <p:cNvPr id="31" name="TextBox 30"/>
+          <p:cNvSpPr txBox="1"/>
+          <p:nvPr/>
+        </p:nvSpPr>
+        <p:spPr>
+          <a:xfrm>
+            <a:off x="8138160" y="4590288"/>
+            <a:ext cx="3566160" cy="457200"/>
+          </a:xfrm>
+          <a:prstGeom prst="rect">
+            <a:avLst/>
+          </a:prstGeom>
+          <a:noFill/>
+        </p:spPr>
+        <p:txBody>
+          <a:bodyPr wrap="square" anchor="t" lIns="25400" rIns="25400" tIns="25400" bIns="25400">
+            <a:spAutoFit/>
+          </a:bodyPr>
+          <a:lstStyle/>
+          <a:p>
+            <a:pPr algn="l">
+              <a:lnSpc>
+                <a:spcPct val="106000"/>
+              </a:lnSpc>
+              <a:spcBef>
+                <a:spcPts val="0"/>
+              </a:spcBef>
+              <a:spcAft>
+                <a:spcPts val="600"/>
+              </a:spcAft>
+            </a:pPr>
+            <a:r>
+              <a:rPr sz="1250" b="0">
+                <a:solidFill>
+                  <a:srgbClr val="221F20"/>
+                </a:solidFill>
+                <a:latin typeface="Lato"/>
+              </a:rPr>
+              <a:t>Independent witness ≠ performer</a:t>
+            </a:r>
+          </a:p>
+        </p:txBody>
+      </p:sp>
+      <p:sp>
+        <p:nvSpPr>
+          <p:cNvPr id="32" name="Oval 31"/>
+          <p:cNvSpPr/>
+          <p:nvPr/>
+        </p:nvSpPr>
+        <p:spPr>
+          <a:xfrm>
+            <a:off x="7772400" y="5184648"/>
+            <a:ext cx="237744" cy="237744"/>
+          </a:xfrm>
+          <a:prstGeom prst="ellipse">
+            <a:avLst/>
+          </a:prstGeom>
+          <a:solidFill>
+            <a:srgbClr val="2F9E6F"/>
+          </a:solidFill>
+          <a:ln>
+            <a:noFill/>
+          </a:ln>
+          <a:effectLst/>
+        </p:spPr>
+        <p:style>
+          <a:lnRef idx="1">
+            <a:schemeClr val="accent1"/>
+          </a:lnRef>
+          <a:fillRef idx="3">
+            <a:schemeClr val="accent1"/>
+          </a:fillRef>
+          <a:effectRef idx="2">
+            <a:schemeClr val="accent1"/>
+          </a:effectRef>
+          <a:fontRef idx="minor">
+            <a:schemeClr val="lt1"/>
+          </a:fontRef>
+        </p:style>
+        <p:txBody>
+          <a:bodyPr rtlCol="0" anchor="ctr"/>
+          <a:lstStyle/>
+          <a:p>
+            <a:pPr algn="ctr"/>
+            <a:r>
+              <a:rPr sz="1000" b="1">
+                <a:solidFill>
+                  <a:srgbClr val="FFFFFF"/>
+                </a:solidFill>
+                <a:latin typeface="Montserrat"/>
+              </a:rPr>
+              <a:t>✓</a:t>
+            </a:r>
+          </a:p>
+        </p:txBody>
+      </p:sp>
+      <p:sp>
+        <p:nvSpPr>
+          <p:cNvPr id="33" name="TextBox 32"/>
+          <p:cNvSpPr txBox="1"/>
+          <p:nvPr/>
+        </p:nvSpPr>
+        <p:spPr>
+          <a:xfrm>
+            <a:off x="8138160" y="5138928"/>
+            <a:ext cx="3566160" cy="457200"/>
+          </a:xfrm>
+          <a:prstGeom prst="rect">
+            <a:avLst/>
+          </a:prstGeom>
+          <a:noFill/>
+        </p:spPr>
+        <p:txBody>
+          <a:bodyPr wrap="square" anchor="t" lIns="25400" rIns="25400" tIns="25400" bIns="25400">
+            <a:spAutoFit/>
+          </a:bodyPr>
+          <a:lstStyle/>
+          <a:p>
+            <a:pPr algn="l">
+              <a:lnSpc>
+                <a:spcPct val="106000"/>
+              </a:lnSpc>
+              <a:spcBef>
+                <a:spcPts val="0"/>
+              </a:spcBef>
+              <a:spcAft>
+                <a:spcPts val="600"/>
+              </a:spcAft>
+            </a:pPr>
+            <a:r>
+              <a:rPr sz="1250" b="0">
+                <a:solidFill>
+                  <a:srgbClr val="221F20"/>
+                </a:solidFill>
+                <a:latin typeface="Lato"/>
+              </a:rPr>
+              <a:t>Blocks procedure until Passed</a:t>
+            </a:r>
+          </a:p>
+        </p:txBody>
+      </p:sp>
+      <p:sp>
+        <p:nvSpPr>
+          <p:cNvPr id="34" name="TextBox 33"/>
+          <p:cNvSpPr txBox="1"/>
+          <p:nvPr/>
+        </p:nvSpPr>
+        <p:spPr>
+          <a:xfrm>
+            <a:off x="548640" y="6217920"/>
+            <a:ext cx="11247120" cy="365760"/>
+          </a:xfrm>
+          <a:prstGeom prst="rect">
+            <a:avLst/>
+          </a:prstGeom>
+          <a:noFill/>
+        </p:spPr>
+        <p:txBody>
+          <a:bodyPr wrap="square" anchor="t" lIns="25400" rIns="25400" tIns="25400" bIns="25400">
+            <a:spAutoFit/>
+          </a:bodyPr>
+          <a:lstStyle/>
+          <a:p>
+            <a:pPr algn="l">
+              <a:lnSpc>
+                <a:spcPct val="106000"/>
+              </a:lnSpc>
+              <a:spcBef>
+                <a:spcPts val="0"/>
+              </a:spcBef>
+              <a:spcAft>
+                <a:spcPts val="600"/>
+              </a:spcAft>
+            </a:pPr>
+            <a:r>
+              <a:rPr sz="1150" b="0">
+                <a:solidFill>
+                  <a:srgbClr val="6C7C7A"/>
+                </a:solidFill>
+                <a:latin typeface="Lato"/>
+              </a:rPr>
+              <a:t>Field-by-field content: OXar_Treatment_Cycle_Tab_Attributes.xlsx + 07-TREATMENT-PLANNING-TAB.md</a:t>
+            </a:r>
+          </a:p>
+        </p:txBody>
+      </p:sp>
+    </p:spTree>
+  </p:cSld>
+  <p:clrMapOvr>
+    <a:masterClrMapping/>
+  </p:clrMapOvr>
+</p:sld>
+</file>
+
+<file path=ppt/slides/slide25.xml><?xml version="1.0" encoding="utf-8"?>
+<p:sld xmlns:a="http://schemas.openxmlformats.org/drawingml/2006/main" xmlns:p="http://schemas.openxmlformats.org/presentationml/2006/main" xmlns:r="http://schemas.openxmlformats.org/officeDocument/2006/relationships">
+  <p:cSld>
+    <p:bg>
+      <p:bgPr>
+        <a:solidFill>
+          <a:srgbClr val="F5F8F7"/>
+        </a:solidFill>
+        <a:effectLst/>
+      </p:bgPr>
+    </p:bg>
+    <p:spTree>
+      <p:nvGrpSpPr>
+        <p:cNvPr id="1" name=""/>
+        <p:cNvGrpSpPr/>
+        <p:nvPr/>
+      </p:nvGrpSpPr>
+      <p:grpSpPr/>
+      <p:sp>
+        <p:nvSpPr>
+          <p:cNvPr id="2" name="Rectangle 1"/>
+          <p:cNvSpPr/>
+          <p:nvPr/>
+        </p:nvSpPr>
+        <p:spPr>
+          <a:xfrm>
+            <a:off x="0" y="0"/>
+            <a:ext cx="12191695" cy="1051560"/>
+          </a:xfrm>
+          <a:prstGeom prst="rect">
+            <a:avLst/>
+          </a:prstGeom>
+          <a:solidFill>
+            <a:srgbClr val="FFFFFF"/>
+          </a:solidFill>
+          <a:ln>
+            <a:noFill/>
+          </a:ln>
+          <a:effectLst/>
+        </p:spPr>
+        <p:style>
+          <a:lnRef idx="1">
+            <a:schemeClr val="accent1"/>
+          </a:lnRef>
+          <a:fillRef idx="3">
+            <a:schemeClr val="accent1"/>
+          </a:fillRef>
+          <a:effectRef idx="2">
+            <a:schemeClr val="accent1"/>
+          </a:effectRef>
+          <a:fontRef idx="minor">
+            <a:schemeClr val="lt1"/>
+          </a:fontRef>
+        </p:style>
+        <p:txBody>
+          <a:bodyPr rtlCol="0" anchor="ctr"/>
+          <a:lstStyle/>
+          <a:p>
+            <a:pPr algn="ctr"/>
+          </a:p>
+        </p:txBody>
+      </p:sp>
+      <p:sp>
+        <p:nvSpPr>
+          <p:cNvPr id="3" name="Rectangle 2"/>
+          <p:cNvSpPr/>
+          <p:nvPr/>
+        </p:nvSpPr>
+        <p:spPr>
+          <a:xfrm>
+            <a:off x="0" y="1051560"/>
+            <a:ext cx="12191695" cy="38100"/>
+          </a:xfrm>
+          <a:prstGeom prst="rect">
+            <a:avLst/>
+          </a:prstGeom>
+          <a:solidFill>
+            <a:srgbClr val="45A59D"/>
+          </a:solidFill>
+          <a:ln>
+            <a:noFill/>
+          </a:ln>
+          <a:effectLst/>
+        </p:spPr>
+        <p:style>
+          <a:lnRef idx="1">
+            <a:schemeClr val="accent1"/>
+          </a:lnRef>
+          <a:fillRef idx="3">
+            <a:schemeClr val="accent1"/>
+          </a:fillRef>
+          <a:effectRef idx="2">
+            <a:schemeClr val="accent1"/>
+          </a:effectRef>
+          <a:fontRef idx="minor">
+            <a:schemeClr val="lt1"/>
+          </a:fontRef>
+        </p:style>
+        <p:txBody>
+          <a:bodyPr rtlCol="0" anchor="ctr"/>
+          <a:lstStyle/>
+          <a:p>
+            <a:pPr algn="ctr"/>
+          </a:p>
+        </p:txBody>
+      </p:sp>
+      <p:sp>
+        <p:nvSpPr>
+          <p:cNvPr id="4" name="TextBox 3"/>
+          <p:cNvSpPr txBox="1"/>
+          <p:nvPr/>
+        </p:nvSpPr>
+        <p:spPr>
+          <a:xfrm>
+            <a:off x="548640" y="146304"/>
+            <a:ext cx="10058400" cy="365760"/>
+          </a:xfrm>
+          <a:prstGeom prst="rect">
+            <a:avLst/>
+          </a:prstGeom>
+          <a:noFill/>
+        </p:spPr>
+        <p:txBody>
+          <a:bodyPr wrap="square" anchor="t" lIns="25400" rIns="25400" tIns="25400" bIns="25400">
+            <a:spAutoFit/>
+          </a:bodyPr>
+          <a:lstStyle/>
+          <a:p>
+            <a:pPr algn="l">
+              <a:lnSpc>
+                <a:spcPct val="106000"/>
+              </a:lnSpc>
+              <a:spcBef>
+                <a:spcPts val="0"/>
+              </a:spcBef>
+              <a:spcAft>
+                <a:spcPts val="600"/>
+              </a:spcAft>
+            </a:pPr>
+            <a:r>
+              <a:rPr sz="1200" b="1">
+                <a:solidFill>
+                  <a:srgbClr val="2F7D76"/>
+                </a:solidFill>
+                <a:latin typeface="Montserrat"/>
+              </a:rPr>
+              <a:t>CRYO STORAGE</a:t>
+            </a:r>
+          </a:p>
+        </p:txBody>
+      </p:sp>
+      <p:sp>
+        <p:nvSpPr>
+          <p:cNvPr id="5" name="TextBox 4"/>
+          <p:cNvSpPr txBox="1"/>
+          <p:nvPr/>
+        </p:nvSpPr>
+        <p:spPr>
+          <a:xfrm>
+            <a:off x="548640" y="402336"/>
+            <a:ext cx="10515600" cy="640080"/>
+          </a:xfrm>
+          <a:prstGeom prst="rect">
+            <a:avLst/>
+          </a:prstGeom>
+          <a:noFill/>
+        </p:spPr>
+        <p:txBody>
+          <a:bodyPr wrap="square" anchor="t" lIns="25400" rIns="25400" tIns="25400" bIns="25400">
+            <a:spAutoFit/>
+          </a:bodyPr>
+          <a:lstStyle/>
+          <a:p>
+            <a:pPr algn="l">
+              <a:lnSpc>
+                <a:spcPct val="106000"/>
+              </a:lnSpc>
+              <a:spcBef>
+                <a:spcPts val="0"/>
+              </a:spcBef>
+              <a:spcAft>
+                <a:spcPts val="600"/>
+              </a:spcAft>
+            </a:pPr>
+            <a:r>
+              <a:rPr sz="2700" b="1">
+                <a:solidFill>
+                  <a:srgbClr val="221F20"/>
+                </a:solidFill>
+                <a:latin typeface="Montserrat"/>
+              </a:rPr>
+              <a:t>Managing cryo tanks</a:t>
+            </a:r>
+          </a:p>
+        </p:txBody>
+      </p:sp>
+      <p:sp>
+        <p:nvSpPr>
+          <p:cNvPr id="6" name="Rounded Rectangle 5"/>
+          <p:cNvSpPr/>
+          <p:nvPr/>
+        </p:nvSpPr>
+        <p:spPr>
+          <a:xfrm>
+            <a:off x="11292840" y="292608"/>
+            <a:ext cx="566928" cy="457200"/>
+          </a:xfrm>
+          <a:prstGeom prst="roundRect">
+            <a:avLst/>
+          </a:prstGeom>
+          <a:solidFill>
+            <a:srgbClr val="EAF5F3"/>
+          </a:solidFill>
+          <a:ln>
+            <a:noFill/>
+          </a:ln>
+          <a:effectLst/>
+        </p:spPr>
+        <p:style>
+          <a:lnRef idx="1">
+            <a:schemeClr val="accent1"/>
+          </a:lnRef>
+          <a:fillRef idx="3">
+            <a:schemeClr val="accent1"/>
+          </a:fillRef>
+          <a:effectRef idx="2">
+            <a:schemeClr val="accent1"/>
+          </a:effectRef>
+          <a:fontRef idx="minor">
+            <a:schemeClr val="lt1"/>
+          </a:fontRef>
+        </p:style>
+        <p:txBody>
+          <a:bodyPr rtlCol="0" anchor="ctr" wrap="none"/>
+          <a:lstStyle/>
+          <a:p>
+            <a:pPr algn="ctr"/>
+            <a:r>
+              <a:rPr sz="1500" b="1">
+                <a:solidFill>
+                  <a:srgbClr val="2F7D76"/>
+                </a:solidFill>
+                <a:latin typeface="Montserrat"/>
+              </a:rPr>
+              <a:t>25</a:t>
+            </a:r>
+          </a:p>
+        </p:txBody>
+      </p:sp>
+      <p:sp>
+        <p:nvSpPr>
+          <p:cNvPr id="7" name="TextBox 6"/>
+          <p:cNvSpPr txBox="1"/>
+          <p:nvPr/>
+        </p:nvSpPr>
+        <p:spPr>
+          <a:xfrm>
+            <a:off x="548640" y="1280160"/>
+            <a:ext cx="11064240" cy="640080"/>
+          </a:xfrm>
+          <a:prstGeom prst="rect">
+            <a:avLst/>
+          </a:prstGeom>
+          <a:noFill/>
+        </p:spPr>
+        <p:txBody>
+          <a:bodyPr wrap="square" anchor="t" lIns="25400" rIns="25400" tIns="25400" bIns="25400">
+            <a:spAutoFit/>
+          </a:bodyPr>
+          <a:lstStyle/>
+          <a:p>
+            <a:pPr algn="l">
+              <a:lnSpc>
+                <a:spcPct val="106000"/>
+              </a:lnSpc>
+              <a:spcBef>
+                <a:spcPts val="0"/>
+              </a:spcBef>
+              <a:spcAft>
+                <a:spcPts val="600"/>
+              </a:spcAft>
+            </a:pPr>
+            <a:r>
+              <a:rPr sz="1600" b="0">
+                <a:solidFill>
+                  <a:srgbClr val="221F20"/>
+                </a:solidFill>
+                <a:latin typeface="Lato"/>
+              </a:rPr>
+              <a:t>Three linked screens — see capacity at a glance, drill into the position hierarchy, and add / edit tanks and slots (manager-gated).</a:t>
+            </a:r>
+          </a:p>
+        </p:txBody>
+      </p:sp>
+      <p:sp>
+        <p:nvSpPr>
+          <p:cNvPr id="8" name="Rounded Rectangle 7"/>
+          <p:cNvSpPr/>
+          <p:nvPr/>
+        </p:nvSpPr>
+        <p:spPr>
+          <a:xfrm>
+            <a:off x="548640" y="2194560"/>
+            <a:ext cx="3611880" cy="2194560"/>
+          </a:xfrm>
+          <a:prstGeom prst="roundRect">
+            <a:avLst/>
+          </a:prstGeom>
+          <a:solidFill>
+            <a:srgbClr val="FFFFFF"/>
+          </a:solidFill>
+          <a:ln w="12700">
+            <a:solidFill>
+              <a:srgbClr val="E4ECEA"/>
+            </a:solidFill>
+          </a:ln>
+          <a:effectLst/>
+        </p:spPr>
+        <p:style>
+          <a:lnRef idx="1">
+            <a:schemeClr val="accent1"/>
+          </a:lnRef>
+          <a:fillRef idx="3">
+            <a:schemeClr val="accent1"/>
+          </a:fillRef>
+          <a:effectRef idx="2">
+            <a:schemeClr val="accent1"/>
+          </a:effectRef>
+          <a:fontRef idx="minor">
+            <a:schemeClr val="lt1"/>
+          </a:fontRef>
+        </p:style>
+        <p:txBody>
+          <a:bodyPr rtlCol="0" anchor="ctr"/>
+          <a:lstStyle/>
+          <a:p>
+            <a:pPr algn="ctr"/>
+          </a:p>
+        </p:txBody>
+      </p:sp>
+      <p:sp>
+        <p:nvSpPr>
+          <p:cNvPr id="9" name="Rectangle 8"/>
+          <p:cNvSpPr/>
+          <p:nvPr/>
+        </p:nvSpPr>
+        <p:spPr>
+          <a:xfrm>
+            <a:off x="548640" y="2194560"/>
+            <a:ext cx="3611880" cy="109728"/>
+          </a:xfrm>
+          <a:prstGeom prst="rect">
+            <a:avLst/>
+          </a:prstGeom>
+          <a:solidFill>
+            <a:srgbClr val="45A59D"/>
+          </a:solidFill>
+          <a:ln>
+            <a:noFill/>
+          </a:ln>
+          <a:effectLst/>
+        </p:spPr>
+        <p:style>
+          <a:lnRef idx="1">
+            <a:schemeClr val="accent1"/>
+          </a:lnRef>
+          <a:fillRef idx="3">
+            <a:schemeClr val="accent1"/>
+          </a:fillRef>
+          <a:effectRef idx="2">
+            <a:schemeClr val="accent1"/>
+          </a:effectRef>
+          <a:fontRef idx="minor">
+            <a:schemeClr val="lt1"/>
+          </a:fontRef>
+        </p:style>
+        <p:txBody>
+          <a:bodyPr rtlCol="0" anchor="ctr"/>
+          <a:lstStyle/>
+          <a:p>
+            <a:pPr algn="ctr"/>
+          </a:p>
+        </p:txBody>
+      </p:sp>
+      <p:sp>
+        <p:nvSpPr>
+          <p:cNvPr id="10" name="Rounded Rectangle 9"/>
+          <p:cNvSpPr/>
+          <p:nvPr/>
+        </p:nvSpPr>
+        <p:spPr>
+          <a:xfrm>
+            <a:off x="822960" y="2514600"/>
+            <a:ext cx="2194560" cy="457200"/>
+          </a:xfrm>
+          <a:prstGeom prst="roundRect">
+            <a:avLst/>
+          </a:prstGeom>
+          <a:solidFill>
+            <a:srgbClr val="45A59D"/>
+          </a:solidFill>
+          <a:ln>
+            <a:noFill/>
+          </a:ln>
+          <a:effectLst/>
+        </p:spPr>
+        <p:style>
+          <a:lnRef idx="1">
+            <a:schemeClr val="accent1"/>
+          </a:lnRef>
+          <a:fillRef idx="3">
+            <a:schemeClr val="accent1"/>
+          </a:fillRef>
+          <a:effectRef idx="2">
+            <a:schemeClr val="accent1"/>
+          </a:effectRef>
+          <a:fontRef idx="minor">
+            <a:schemeClr val="lt1"/>
+          </a:fontRef>
+        </p:style>
+        <p:txBody>
+          <a:bodyPr rtlCol="0" anchor="ctr" wrap="square"/>
+          <a:lstStyle/>
+          <a:p>
+            <a:pPr algn="ctr"/>
+            <a:r>
+              <a:rPr sz="1300" b="1">
+                <a:solidFill>
+                  <a:srgbClr val="FFFFFF"/>
+                </a:solidFill>
+                <a:latin typeface="Montserrat"/>
+              </a:rPr>
+              <a:t>TANK WALL</a:t>
+            </a:r>
+          </a:p>
+        </p:txBody>
+      </p:sp>
+      <p:sp>
+        <p:nvSpPr>
+          <p:cNvPr id="11" name="TextBox 10"/>
+          <p:cNvSpPr txBox="1"/>
+          <p:nvPr/>
+        </p:nvSpPr>
+        <p:spPr>
+          <a:xfrm>
+            <a:off x="822960" y="3154680"/>
+            <a:ext cx="3063240" cy="1097280"/>
+          </a:xfrm>
+          <a:prstGeom prst="rect">
+            <a:avLst/>
+          </a:prstGeom>
+          <a:noFill/>
+        </p:spPr>
+        <p:txBody>
+          <a:bodyPr wrap="square" anchor="t" lIns="25400" rIns="25400" tIns="25400" bIns="25400">
+            <a:spAutoFit/>
+          </a:bodyPr>
+          <a:lstStyle/>
+          <a:p>
+            <a:pPr algn="l">
+              <a:lnSpc>
+                <a:spcPct val="106000"/>
+              </a:lnSpc>
+              <a:spcBef>
+                <a:spcPts val="0"/>
+              </a:spcBef>
+              <a:spcAft>
+                <a:spcPts val="600"/>
+              </a:spcAft>
+            </a:pPr>
+            <a:r>
+              <a:rPr sz="1300" b="0">
+                <a:solidFill>
+                  <a:srgbClr val="221F20"/>
+                </a:solidFill>
+                <a:latin typeface="Lato"/>
+              </a:rPr>
+              <a:t>Card per tank with a fill gauge + status pill (OK / Low N2 / Alarm). + Add tank.</a:t>
+            </a:r>
+          </a:p>
+        </p:txBody>
+      </p:sp>
+      <p:sp>
+        <p:nvSpPr>
+          <p:cNvPr id="12" name="Rounded Rectangle 11"/>
+          <p:cNvSpPr/>
+          <p:nvPr/>
+        </p:nvSpPr>
+        <p:spPr>
+          <a:xfrm>
+            <a:off x="4343400" y="2194560"/>
+            <a:ext cx="3611880" cy="2194560"/>
+          </a:xfrm>
+          <a:prstGeom prst="roundRect">
+            <a:avLst/>
+          </a:prstGeom>
+          <a:solidFill>
+            <a:srgbClr val="FFFFFF"/>
+          </a:solidFill>
+          <a:ln w="12700">
+            <a:solidFill>
+              <a:srgbClr val="E4ECEA"/>
+            </a:solidFill>
+          </a:ln>
+          <a:effectLst/>
+        </p:spPr>
+        <p:style>
+          <a:lnRef idx="1">
+            <a:schemeClr val="accent1"/>
+          </a:lnRef>
+          <a:fillRef idx="3">
+            <a:schemeClr val="accent1"/>
+          </a:fillRef>
+          <a:effectRef idx="2">
+            <a:schemeClr val="accent1"/>
+          </a:effectRef>
+          <a:fontRef idx="minor">
+            <a:schemeClr val="lt1"/>
+          </a:fontRef>
+        </p:style>
+        <p:txBody>
+          <a:bodyPr rtlCol="0" anchor="ctr"/>
+          <a:lstStyle/>
+          <a:p>
+            <a:pPr algn="ctr"/>
+          </a:p>
+        </p:txBody>
+      </p:sp>
+      <p:sp>
+        <p:nvSpPr>
+          <p:cNvPr id="13" name="Rectangle 12"/>
+          <p:cNvSpPr/>
+          <p:nvPr/>
+        </p:nvSpPr>
+        <p:spPr>
+          <a:xfrm>
+            <a:off x="4343400" y="2194560"/>
+            <a:ext cx="3611880" cy="109728"/>
+          </a:xfrm>
+          <a:prstGeom prst="rect">
+            <a:avLst/>
+          </a:prstGeom>
+          <a:solidFill>
+            <a:srgbClr val="2F7D76"/>
+          </a:solidFill>
+          <a:ln>
+            <a:noFill/>
+          </a:ln>
+          <a:effectLst/>
+        </p:spPr>
+        <p:style>
+          <a:lnRef idx="1">
+            <a:schemeClr val="accent1"/>
+          </a:lnRef>
+          <a:fillRef idx="3">
+            <a:schemeClr val="accent1"/>
+          </a:fillRef>
+          <a:effectRef idx="2">
+            <a:schemeClr val="accent1"/>
+          </a:effectRef>
+          <a:fontRef idx="minor">
+            <a:schemeClr val="lt1"/>
+          </a:fontRef>
+        </p:style>
+        <p:txBody>
+          <a:bodyPr rtlCol="0" anchor="ctr"/>
+          <a:lstStyle/>
+          <a:p>
+            <a:pPr algn="ctr"/>
+          </a:p>
+        </p:txBody>
+      </p:sp>
+      <p:sp>
+        <p:nvSpPr>
+          <p:cNvPr id="14" name="Rounded Rectangle 13"/>
+          <p:cNvSpPr/>
+          <p:nvPr/>
+        </p:nvSpPr>
+        <p:spPr>
+          <a:xfrm>
+            <a:off x="4617720" y="2514600"/>
+            <a:ext cx="2194560" cy="457200"/>
+          </a:xfrm>
+          <a:prstGeom prst="roundRect">
+            <a:avLst/>
+          </a:prstGeom>
+          <a:solidFill>
+            <a:srgbClr val="2F7D76"/>
+          </a:solidFill>
+          <a:ln>
+            <a:noFill/>
+          </a:ln>
+          <a:effectLst/>
+        </p:spPr>
+        <p:style>
+          <a:lnRef idx="1">
+            <a:schemeClr val="accent1"/>
+          </a:lnRef>
+          <a:fillRef idx="3">
+            <a:schemeClr val="accent1"/>
+          </a:fillRef>
+          <a:effectRef idx="2">
+            <a:schemeClr val="accent1"/>
+          </a:effectRef>
+          <a:fontRef idx="minor">
+            <a:schemeClr val="lt1"/>
+          </a:fontRef>
+        </p:style>
+        <p:txBody>
+          <a:bodyPr rtlCol="0" anchor="ctr" wrap="square"/>
+          <a:lstStyle/>
+          <a:p>
+            <a:pPr algn="ctr"/>
+            <a:r>
+              <a:rPr sz="1300" b="1">
+                <a:solidFill>
+                  <a:srgbClr val="FFFFFF"/>
+                </a:solidFill>
+                <a:latin typeface="Montserrat"/>
+              </a:rPr>
+              <a:t>TANK DETAIL</a:t>
+            </a:r>
+          </a:p>
+        </p:txBody>
+      </p:sp>
+      <p:sp>
+        <p:nvSpPr>
+          <p:cNvPr id="15" name="TextBox 14"/>
+          <p:cNvSpPr txBox="1"/>
+          <p:nvPr/>
+        </p:nvSpPr>
+        <p:spPr>
+          <a:xfrm>
+            <a:off x="4617720" y="3154680"/>
+            <a:ext cx="3063240" cy="1097280"/>
+          </a:xfrm>
+          <a:prstGeom prst="rect">
+            <a:avLst/>
+          </a:prstGeom>
+          <a:noFill/>
+        </p:spPr>
+        <p:txBody>
+          <a:bodyPr wrap="square" anchor="t" lIns="25400" rIns="25400" tIns="25400" bIns="25400">
+            <a:spAutoFit/>
+          </a:bodyPr>
+          <a:lstStyle/>
+          <a:p>
+            <a:pPr algn="l">
+              <a:lnSpc>
+                <a:spcPct val="106000"/>
+              </a:lnSpc>
+              <a:spcBef>
+                <a:spcPts val="0"/>
+              </a:spcBef>
+              <a:spcAft>
+                <a:spcPts val="600"/>
+              </a:spcAft>
+            </a:pPr>
+            <a:r>
+              <a:rPr sz="1300" b="0">
+                <a:solidFill>
+                  <a:srgbClr val="221F20"/>
+                </a:solidFill>
+                <a:latin typeface="Lato"/>
+              </a:rPr>
+              <a:t>Canister -&gt; Goblet -&gt; Straw/Vial tree; slots coloured by status &amp; type; add/edit/retire.</a:t>
+            </a:r>
+          </a:p>
+        </p:txBody>
+      </p:sp>
+      <p:sp>
+        <p:nvSpPr>
+          <p:cNvPr id="16" name="Rounded Rectangle 15"/>
+          <p:cNvSpPr/>
+          <p:nvPr/>
+        </p:nvSpPr>
+        <p:spPr>
+          <a:xfrm>
+            <a:off x="8138160" y="2194560"/>
+            <a:ext cx="3611880" cy="2194560"/>
+          </a:xfrm>
+          <a:prstGeom prst="roundRect">
+            <a:avLst/>
+          </a:prstGeom>
+          <a:solidFill>
+            <a:srgbClr val="FFFFFF"/>
+          </a:solidFill>
+          <a:ln w="12700">
+            <a:solidFill>
+              <a:srgbClr val="E4ECEA"/>
+            </a:solidFill>
+          </a:ln>
+          <a:effectLst/>
+        </p:spPr>
+        <p:style>
+          <a:lnRef idx="1">
+            <a:schemeClr val="accent1"/>
+          </a:lnRef>
+          <a:fillRef idx="3">
+            <a:schemeClr val="accent1"/>
+          </a:fillRef>
+          <a:effectRef idx="2">
+            <a:schemeClr val="accent1"/>
+          </a:effectRef>
+          <a:fontRef idx="minor">
+            <a:schemeClr val="lt1"/>
+          </a:fontRef>
+        </p:style>
+        <p:txBody>
+          <a:bodyPr rtlCol="0" anchor="ctr"/>
+          <a:lstStyle/>
+          <a:p>
+            <a:pPr algn="ctr"/>
+          </a:p>
+        </p:txBody>
+      </p:sp>
+      <p:sp>
+        <p:nvSpPr>
+          <p:cNvPr id="17" name="Rectangle 16"/>
+          <p:cNvSpPr/>
+          <p:nvPr/>
+        </p:nvSpPr>
+        <p:spPr>
+          <a:xfrm>
+            <a:off x="8138160" y="2194560"/>
+            <a:ext cx="3611880" cy="109728"/>
+          </a:xfrm>
+          <a:prstGeom prst="rect">
+            <a:avLst/>
+          </a:prstGeom>
+          <a:solidFill>
+            <a:srgbClr val="7A5CC0"/>
+          </a:solidFill>
+          <a:ln>
+            <a:noFill/>
+          </a:ln>
+          <a:effectLst/>
+        </p:spPr>
+        <p:style>
+          <a:lnRef idx="1">
+            <a:schemeClr val="accent1"/>
+          </a:lnRef>
+          <a:fillRef idx="3">
+            <a:schemeClr val="accent1"/>
+          </a:fillRef>
+          <a:effectRef idx="2">
+            <a:schemeClr val="accent1"/>
+          </a:effectRef>
+          <a:fontRef idx="minor">
+            <a:schemeClr val="lt1"/>
+          </a:fontRef>
+        </p:style>
+        <p:txBody>
+          <a:bodyPr rtlCol="0" anchor="ctr"/>
+          <a:lstStyle/>
+          <a:p>
+            <a:pPr algn="ctr"/>
+          </a:p>
+        </p:txBody>
+      </p:sp>
+      <p:sp>
+        <p:nvSpPr>
+          <p:cNvPr id="18" name="Rounded Rectangle 17"/>
+          <p:cNvSpPr/>
+          <p:nvPr/>
+        </p:nvSpPr>
+        <p:spPr>
+          <a:xfrm>
+            <a:off x="8412480" y="2514600"/>
+            <a:ext cx="2194560" cy="457200"/>
+          </a:xfrm>
+          <a:prstGeom prst="roundRect">
+            <a:avLst/>
+          </a:prstGeom>
+          <a:solidFill>
+            <a:srgbClr val="7A5CC0"/>
+          </a:solidFill>
+          <a:ln>
+            <a:noFill/>
+          </a:ln>
+          <a:effectLst/>
+        </p:spPr>
+        <p:style>
+          <a:lnRef idx="1">
+            <a:schemeClr val="accent1"/>
+          </a:lnRef>
+          <a:fillRef idx="3">
+            <a:schemeClr val="accent1"/>
+          </a:fillRef>
+          <a:effectRef idx="2">
+            <a:schemeClr val="accent1"/>
+          </a:effectRef>
+          <a:fontRef idx="minor">
+            <a:schemeClr val="lt1"/>
+          </a:fontRef>
+        </p:style>
+        <p:txBody>
+          <a:bodyPr rtlCol="0" anchor="ctr" wrap="square"/>
+          <a:lstStyle/>
+          <a:p>
+            <a:pPr algn="ctr"/>
+            <a:r>
+              <a:rPr sz="1300" b="1">
+                <a:solidFill>
+                  <a:srgbClr val="FFFFFF"/>
+                </a:solidFill>
+                <a:latin typeface="Montserrat"/>
+              </a:rPr>
+              <a:t>INVENTORY</a:t>
+            </a:r>
+          </a:p>
+        </p:txBody>
+      </p:sp>
+      <p:sp>
+        <p:nvSpPr>
+          <p:cNvPr id="19" name="TextBox 18"/>
+          <p:cNvSpPr txBox="1"/>
+          <p:nvPr/>
+        </p:nvSpPr>
+        <p:spPr>
+          <a:xfrm>
+            <a:off x="8412480" y="3154680"/>
+            <a:ext cx="3063240" cy="1097280"/>
+          </a:xfrm>
+          <a:prstGeom prst="rect">
+            <a:avLst/>
+          </a:prstGeom>
+          <a:noFill/>
+        </p:spPr>
+        <p:txBody>
+          <a:bodyPr wrap="square" anchor="t" lIns="25400" rIns="25400" tIns="25400" bIns="25400">
+            <a:spAutoFit/>
+          </a:bodyPr>
+          <a:lstStyle/>
+          <a:p>
+            <a:pPr algn="l">
+              <a:lnSpc>
+                <a:spcPct val="106000"/>
+              </a:lnSpc>
+              <a:spcBef>
+                <a:spcPts val="0"/>
+              </a:spcBef>
+              <a:spcAft>
+                <a:spcPts val="600"/>
+              </a:spcAft>
+            </a:pPr>
+            <a:r>
+              <a:rPr sz="1300" b="0">
+                <a:solidFill>
+                  <a:srgbClr val="221F20"/>
+                </a:solidFill>
+                <a:latin typeface="Lato"/>
+              </a:rPr>
+              <a:t>Who's in this tank: patient, specimen ID, material, freeze date, goblet/straw.</a:t>
+            </a:r>
+          </a:p>
+        </p:txBody>
+      </p:sp>
+      <p:sp>
+        <p:nvSpPr>
+          <p:cNvPr id="20" name="Rounded Rectangle 19"/>
+          <p:cNvSpPr/>
+          <p:nvPr/>
+        </p:nvSpPr>
+        <p:spPr>
+          <a:xfrm>
+            <a:off x="548640" y="4709160"/>
+            <a:ext cx="11247120" cy="1417320"/>
+          </a:xfrm>
+          <a:prstGeom prst="roundRect">
+            <a:avLst/>
+          </a:prstGeom>
+          <a:solidFill>
+            <a:srgbClr val="EAF5F3"/>
+          </a:solidFill>
+          <a:ln>
+            <a:noFill/>
+          </a:ln>
+          <a:effectLst/>
+        </p:spPr>
+        <p:style>
+          <a:lnRef idx="1">
+            <a:schemeClr val="accent1"/>
+          </a:lnRef>
+          <a:fillRef idx="3">
+            <a:schemeClr val="accent1"/>
+          </a:fillRef>
+          <a:effectRef idx="2">
+            <a:schemeClr val="accent1"/>
+          </a:effectRef>
+          <a:fontRef idx="minor">
+            <a:schemeClr val="lt1"/>
+          </a:fontRef>
+        </p:style>
+        <p:txBody>
+          <a:bodyPr rtlCol="0" anchor="ctr"/>
+          <a:lstStyle/>
+          <a:p>
+            <a:pPr algn="ctr"/>
+          </a:p>
+        </p:txBody>
+      </p:sp>
+      <p:sp>
+        <p:nvSpPr>
+          <p:cNvPr id="21" name="TextBox 20"/>
+          <p:cNvSpPr txBox="1"/>
+          <p:nvPr/>
+        </p:nvSpPr>
+        <p:spPr>
+          <a:xfrm>
+            <a:off x="777240" y="4828032"/>
+            <a:ext cx="10789920" cy="365760"/>
+          </a:xfrm>
+          <a:prstGeom prst="rect">
+            <a:avLst/>
+          </a:prstGeom>
+          <a:noFill/>
+        </p:spPr>
+        <p:txBody>
+          <a:bodyPr wrap="square" anchor="t" lIns="25400" rIns="25400" tIns="25400" bIns="25400">
+            <a:spAutoFit/>
+          </a:bodyPr>
+          <a:lstStyle/>
+          <a:p>
+            <a:pPr algn="l">
+              <a:lnSpc>
+                <a:spcPct val="106000"/>
+              </a:lnSpc>
+              <a:spcBef>
+                <a:spcPts val="0"/>
+              </a:spcBef>
+              <a:spcAft>
+                <a:spcPts val="600"/>
+              </a:spcAft>
+            </a:pPr>
+            <a:r>
+              <a:rPr sz="1300" b="1">
+                <a:solidFill>
+                  <a:srgbClr val="2F7D76"/>
+                </a:solidFill>
+                <a:latin typeface="Lato"/>
+              </a:rPr>
+              <a:t>Backend (all in the OXAR solution): </a:t>
+            </a:r>
+            <a:r>
+              <a:rPr sz="1300" b="1">
+                <a:solidFill>
+                  <a:srgbClr val="221F20"/>
+                </a:solidFill>
+                <a:latin typeface="Consolas"/>
+              </a:rPr>
+              <a:t>CryoTank + CryoLocation full CRUD + CryoTank/GetInventory</a:t>
+            </a:r>
+          </a:p>
+        </p:txBody>
+      </p:sp>
+      <p:sp>
+        <p:nvSpPr>
+          <p:cNvPr id="22" name="TextBox 21"/>
+          <p:cNvSpPr txBox="1"/>
+          <p:nvPr/>
+        </p:nvSpPr>
+        <p:spPr>
+          <a:xfrm>
+            <a:off x="777240" y="5257800"/>
+            <a:ext cx="10789920" cy="822960"/>
+          </a:xfrm>
+          <a:prstGeom prst="rect">
+            <a:avLst/>
+          </a:prstGeom>
+          <a:noFill/>
+        </p:spPr>
+        <p:txBody>
+          <a:bodyPr wrap="square" anchor="t" lIns="25400" rIns="25400" tIns="25400" bIns="25400">
+            <a:spAutoFit/>
+          </a:bodyPr>
+          <a:lstStyle/>
+          <a:p>
+            <a:pPr algn="l">
+              <a:lnSpc>
+                <a:spcPct val="106000"/>
+              </a:lnSpc>
+              <a:spcBef>
+                <a:spcPts val="0"/>
+              </a:spcBef>
+              <a:spcAft>
+                <a:spcPts val="600"/>
+              </a:spcAft>
+            </a:pPr>
+            <a:r>
+              <a:rPr sz="1250" b="0">
+                <a:solidFill>
+                  <a:srgbClr val="6C7C7A"/>
+                </a:solidFill>
+                <a:latin typeface="Lato"/>
+              </a:rPr>
+              <a:t>Freeze picks a free slot → flips it Occupied; thaw frees it (→ Available), so the tank views always reflect live occupancy. Fill gauge: green &lt;80%, amber 80-95%, red ≥95%.</a:t>
             </a:r>
           </a:p>
         </p:txBody>

</xml_diff>